<commit_message>
Rename example script and notebook
</commit_message>
<xml_diff>
--- a/workshops/week01/vscode_slides.pptx
+++ b/workshops/week01/vscode_slides.pptx
@@ -135,7 +135,7 @@
   <pc:docChgLst>
     <pc:chgData name="Isabel Montero Hovdahl" userId="e6c00a4d-4ab5-475c-996d-11be2680c122" providerId="ADAL" clId="{492A1D5D-B8BD-4473-8F28-59B786D7141F}"/>
     <pc:docChg chg="undo custSel addSld delSld modSld sldOrd">
-      <pc:chgData name="Isabel Montero Hovdahl" userId="e6c00a4d-4ab5-475c-996d-11be2680c122" providerId="ADAL" clId="{492A1D5D-B8BD-4473-8F28-59B786D7141F}" dt="2026-08-04T08:47:51.265" v="4063" actId="20577"/>
+      <pc:chgData name="Isabel Montero Hovdahl" userId="e6c00a4d-4ab5-475c-996d-11be2680c122" providerId="ADAL" clId="{492A1D5D-B8BD-4473-8F28-59B786D7141F}" dt="2026-08-07T10:50:40.818" v="4079" actId="20577"/>
       <pc:docMkLst>
         <pc:docMk/>
       </pc:docMkLst>
@@ -476,7 +476,7 @@
         </pc:spChg>
       </pc:sldChg>
       <pc:sldChg chg="addSp delSp modSp mod">
-        <pc:chgData name="Isabel Montero Hovdahl" userId="e6c00a4d-4ab5-475c-996d-11be2680c122" providerId="ADAL" clId="{492A1D5D-B8BD-4473-8F28-59B786D7141F}" dt="2026-07-24T11:04:11.313" v="4017" actId="207"/>
+        <pc:chgData name="Isabel Montero Hovdahl" userId="e6c00a4d-4ab5-475c-996d-11be2680c122" providerId="ADAL" clId="{492A1D5D-B8BD-4473-8F28-59B786D7141F}" dt="2026-08-07T10:49:27.821" v="4077" actId="6549"/>
         <pc:sldMkLst>
           <pc:docMk/>
           <pc:sldMk cId="0" sldId="266"/>
@@ -522,7 +522,7 @@
           </ac:spMkLst>
         </pc:spChg>
         <pc:spChg chg="add del mod">
-          <ac:chgData name="Isabel Montero Hovdahl" userId="e6c00a4d-4ab5-475c-996d-11be2680c122" providerId="ADAL" clId="{492A1D5D-B8BD-4473-8F28-59B786D7141F}" dt="2026-07-24T10:35:22.013" v="3830" actId="20577"/>
+          <ac:chgData name="Isabel Montero Hovdahl" userId="e6c00a4d-4ab5-475c-996d-11be2680c122" providerId="ADAL" clId="{492A1D5D-B8BD-4473-8F28-59B786D7141F}" dt="2026-08-07T10:49:27.821" v="4077" actId="6549"/>
           <ac:spMkLst>
             <pc:docMk/>
             <pc:sldMk cId="0" sldId="266"/>
@@ -694,7 +694,7 @@
         </pc:spChg>
       </pc:sldChg>
       <pc:sldChg chg="addSp delSp modSp mod ord">
-        <pc:chgData name="Isabel Montero Hovdahl" userId="e6c00a4d-4ab5-475c-996d-11be2680c122" providerId="ADAL" clId="{492A1D5D-B8BD-4473-8F28-59B786D7141F}" dt="2026-07-24T11:04:36.022" v="4021" actId="207"/>
+        <pc:chgData name="Isabel Montero Hovdahl" userId="e6c00a4d-4ab5-475c-996d-11be2680c122" providerId="ADAL" clId="{492A1D5D-B8BD-4473-8F28-59B786D7141F}" dt="2026-08-07T10:50:40.818" v="4079" actId="20577"/>
         <pc:sldMkLst>
           <pc:docMk/>
           <pc:sldMk cId="0" sldId="274"/>
@@ -772,7 +772,7 @@
           </ac:spMkLst>
         </pc:spChg>
         <pc:spChg chg="mod">
-          <ac:chgData name="Isabel Montero Hovdahl" userId="e6c00a4d-4ab5-475c-996d-11be2680c122" providerId="ADAL" clId="{492A1D5D-B8BD-4473-8F28-59B786D7141F}" dt="2026-07-20T09:03:45.597" v="2490" actId="1076"/>
+          <ac:chgData name="Isabel Montero Hovdahl" userId="e6c00a4d-4ab5-475c-996d-11be2680c122" providerId="ADAL" clId="{492A1D5D-B8BD-4473-8F28-59B786D7141F}" dt="2026-08-07T10:50:40.818" v="4079" actId="20577"/>
           <ac:spMkLst>
             <pc:docMk/>
             <pc:sldMk cId="0" sldId="274"/>
@@ -962,7 +962,7 @@
         </pc:picChg>
       </pc:sldChg>
       <pc:sldChg chg="delSp modSp mod">
-        <pc:chgData name="Isabel Montero Hovdahl" userId="e6c00a4d-4ab5-475c-996d-11be2680c122" providerId="ADAL" clId="{492A1D5D-B8BD-4473-8F28-59B786D7141F}" dt="2026-07-24T11:03:00.003" v="4011" actId="207"/>
+        <pc:chgData name="Isabel Montero Hovdahl" userId="e6c00a4d-4ab5-475c-996d-11be2680c122" providerId="ADAL" clId="{492A1D5D-B8BD-4473-8F28-59B786D7141F}" dt="2026-08-07T10:47:57.991" v="4076" actId="20577"/>
         <pc:sldMkLst>
           <pc:docMk/>
           <pc:sldMk cId="0" sldId="280"/>
@@ -976,7 +976,7 @@
           </ac:spMkLst>
         </pc:spChg>
         <pc:spChg chg="mod">
-          <ac:chgData name="Isabel Montero Hovdahl" userId="e6c00a4d-4ab5-475c-996d-11be2680c122" providerId="ADAL" clId="{492A1D5D-B8BD-4473-8F28-59B786D7141F}" dt="2026-07-24T10:22:59.289" v="3218" actId="403"/>
+          <ac:chgData name="Isabel Montero Hovdahl" userId="e6c00a4d-4ab5-475c-996d-11be2680c122" providerId="ADAL" clId="{492A1D5D-B8BD-4473-8F28-59B786D7141F}" dt="2026-08-07T10:47:57.991" v="4076" actId="20577"/>
           <ac:spMkLst>
             <pc:docMk/>
             <pc:sldMk cId="0" sldId="280"/>
@@ -3701,7 +3701,7 @@
                 <a:ea typeface="Calibri" pitchFamily="34" charset="-122"/>
                 <a:cs typeface="Calibri" pitchFamily="34" charset="-120"/>
               </a:rPr>
-              <a:t>: Instead of the terminal, you can use File explorer / Finder to create the folder. The important things is that you know how to navigate to this folder!</a:t>
+              <a:t>: Instead of the terminal, you can use File explorer / Finder to create the folder. The important thing is that you know how to navigate to this folder!</a:t>
             </a:r>
             <a:endParaRPr lang="en-US" sz="1600" dirty="0"/>
           </a:p>
@@ -3740,7 +3740,7 @@
                 <a:ea typeface="Calibri" pitchFamily="34" charset="-122"/>
                 <a:cs typeface="Calibri" pitchFamily="34" charset="-120"/>
               </a:rPr>
-              <a:t>10</a:t>
+              <a:t>9</a:t>
             </a:r>
             <a:endParaRPr lang="en-US" sz="900" dirty="0"/>
           </a:p>
@@ -4497,7 +4497,7 @@
                 <a:ea typeface="Calibri" pitchFamily="34" charset="-122"/>
                 <a:cs typeface="Calibri" pitchFamily="34" charset="-120"/>
               </a:rPr>
-              <a:t>11</a:t>
+              <a:t>10</a:t>
             </a:r>
             <a:endParaRPr lang="en-US" sz="900" dirty="0"/>
           </a:p>
@@ -5126,7 +5126,7 @@
                 <a:ea typeface="Calibri" pitchFamily="34" charset="-122"/>
                 <a:cs typeface="Calibri" pitchFamily="34" charset="-120"/>
               </a:rPr>
-              <a:t>15</a:t>
+              <a:t>11</a:t>
             </a:r>
             <a:endParaRPr lang="en-US" sz="900" dirty="0"/>
           </a:p>
@@ -5463,7 +5463,7 @@
                 <a:ea typeface="Calibri" pitchFamily="34" charset="-122"/>
                 <a:cs typeface="Calibri" pitchFamily="34" charset="-120"/>
               </a:rPr>
-              <a:t>16</a:t>
+              <a:t>12</a:t>
             </a:r>
             <a:endParaRPr lang="en-US" sz="900" dirty="0"/>
           </a:p>
@@ -6062,7 +6062,7 @@
                 <a:ea typeface="Calibri" pitchFamily="34" charset="-122"/>
                 <a:cs typeface="Calibri" pitchFamily="34" charset="-120"/>
               </a:rPr>
-              <a:t>Watch the output appear in the terminal in VS code</a:t>
+              <a:t>Watch the output appear in the terminal in VS Code</a:t>
             </a:r>
             <a:endParaRPr lang="en-US" sz="1600" dirty="0"/>
           </a:p>
@@ -6101,7 +6101,7 @@
                 <a:ea typeface="Calibri" pitchFamily="34" charset="-122"/>
                 <a:cs typeface="Calibri" pitchFamily="34" charset="-120"/>
               </a:rPr>
-              <a:t>18</a:t>
+              <a:t>13</a:t>
             </a:r>
             <a:endParaRPr lang="en-US" sz="900" dirty="0"/>
           </a:p>
@@ -6918,7 +6918,7 @@
                 <a:ea typeface="Calibri" pitchFamily="34" charset="-122"/>
                 <a:cs typeface="Calibri" pitchFamily="34" charset="-120"/>
               </a:rPr>
-              <a:t>20</a:t>
+              <a:t>14</a:t>
             </a:r>
             <a:endParaRPr lang="en-US" sz="900" dirty="0"/>
           </a:p>
@@ -7652,7 +7652,7 @@
                 <a:ea typeface="Calibri" pitchFamily="34" charset="-122"/>
                 <a:cs typeface="Calibri" pitchFamily="34" charset="-120"/>
               </a:rPr>
-              <a:t>22</a:t>
+              <a:t>15</a:t>
             </a:r>
             <a:endParaRPr lang="en-US" sz="900" dirty="0"/>
           </a:p>
@@ -7886,7 +7886,7 @@
                 <a:ea typeface="Calibri" pitchFamily="34" charset="-122"/>
                 <a:cs typeface="Calibri" pitchFamily="34" charset="-120"/>
               </a:rPr>
-              <a:t>Course material lives on GitHub </a:t>
+              <a:t>Course material lives on GitHub — that is always the current version</a:t>
             </a:r>
             <a:endParaRPr lang="en-US" sz="1600" dirty="0"/>
           </a:p>
@@ -7907,7 +7907,7 @@
                 <a:ea typeface="Calibri" pitchFamily="34" charset="-122"/>
                 <a:cs typeface="Calibri" pitchFamily="34" charset="-120"/>
               </a:rPr>
-              <a:t>A ready-made download link is posted on Canvas for each week</a:t>
+              <a:t>Each week, a link to that week’s folder is posted on Canvas</a:t>
             </a:r>
             <a:endParaRPr lang="en-US" sz="1600" dirty="0"/>
           </a:p>
@@ -7928,7 +7928,28 @@
                 <a:ea typeface="Calibri" pitchFamily="34" charset="-122"/>
                 <a:cs typeface="Calibri" pitchFamily="34" charset="-120"/>
               </a:rPr>
-              <a:t>You'll repeat this exact step every week of the course</a:t>
+              <a:t>GitHub has no “download folder” button — you download the files one at a time</a:t>
+            </a:r>
+            <a:endParaRPr lang="en-US" sz="1600" dirty="0"/>
+          </a:p>
+          <a:p>
+            <a:pPr marL="342900" indent="-342900" algn="l">
+              <a:spcAft>
+                <a:spcPts val="1200"/>
+              </a:spcAft>
+              <a:buSzPct val="100000"/>
+              <a:buChar char="•"/>
+            </a:pPr>
+            <a:r>
+              <a:rPr lang="en-US" sz="1600" dirty="0">
+                <a:solidFill>
+                  <a:srgbClr val="1E2761"/>
+                </a:solidFill>
+                <a:latin typeface="Calibri" pitchFamily="34" charset="0"/>
+                <a:ea typeface="Calibri" pitchFamily="34" charset="-122"/>
+                <a:cs typeface="Calibri" pitchFamily="34" charset="-120"/>
+              </a:rPr>
+              <a:t>You’ll repeat this step every week of the course</a:t>
             </a:r>
             <a:endParaRPr lang="en-US" sz="1600" dirty="0"/>
           </a:p>
@@ -7967,7 +7988,7 @@
                 <a:ea typeface="Calibri" pitchFamily="34" charset="-122"/>
                 <a:cs typeface="Calibri" pitchFamily="34" charset="-120"/>
               </a:rPr>
-              <a:t>13</a:t>
+              <a:t>16</a:t>
             </a:r>
             <a:endParaRPr lang="en-US" sz="900" dirty="0"/>
           </a:p>
@@ -8263,7 +8284,7 @@
                 <a:ea typeface="Calibri" pitchFamily="34" charset="-122"/>
                 <a:cs typeface="Calibri" pitchFamily="34" charset="-120"/>
               </a:rPr>
-              <a:t>Download this week's ZIP from the Canvas link</a:t>
+              <a:t>Open Canvas and click this week’s link — it opens the week01 folder on GitHub</a:t>
             </a:r>
             <a:endParaRPr lang="en-US" sz="1600" dirty="0"/>
           </a:p>
@@ -8368,7 +8389,7 @@
                 <a:ea typeface="Calibri" pitchFamily="34" charset="-122"/>
                 <a:cs typeface="Calibri" pitchFamily="34" charset="-120"/>
               </a:rPr>
-              <a:t>Unzip it</a:t>
+              <a:t>Click example_script.py, then the download button. Do the same for example_notebook.ipynb</a:t>
             </a:r>
             <a:endParaRPr lang="en-US" sz="1600" dirty="0"/>
           </a:p>
@@ -8473,7 +8494,7 @@
                 <a:ea typeface="Calibri" pitchFamily="34" charset="-122"/>
                 <a:cs typeface="Calibri" pitchFamily="34" charset="-120"/>
               </a:rPr>
-              <a:t>Move the files into your week01 folder</a:t>
+              <a:t>Move both into your week01 folder, next to the hello.py you wrote</a:t>
             </a:r>
             <a:endParaRPr lang="en-US" sz="1600" dirty="0"/>
           </a:p>
@@ -8617,7 +8638,7 @@
                 <a:ea typeface="Calibri" pitchFamily="34" charset="-122"/>
                 <a:cs typeface="Calibri" pitchFamily="34" charset="-120"/>
               </a:rPr>
-              <a:t>14</a:t>
+              <a:t>17</a:t>
             </a:r>
             <a:endParaRPr lang="en-US" sz="900" dirty="0"/>
           </a:p>
@@ -10592,7 +10613,7 @@
                 <a:ea typeface="Calibri" pitchFamily="34" charset="-122"/>
                 <a:cs typeface="Calibri" pitchFamily="34" charset="-120"/>
               </a:rPr>
-              <a:t>Mac’s Terminal is Unix-based but Windows’ shell (PowerShell) speaks different command than Unix → Use Git Bash on Windows</a:t>
+              <a:t>Mac’s Terminal is Unix-based but Windows’ shell speaks different command than Unix → Use Git Bash on Windows</a:t>
             </a:r>
           </a:p>
         </p:txBody>
@@ -11217,7 +11238,7 @@
                 <a:ea typeface="Calibri" pitchFamily="34" charset="-122"/>
                 <a:cs typeface="Calibri" pitchFamily="34" charset="-120"/>
               </a:rPr>
-              <a:t>3</a:t>
+              <a:t>4</a:t>
             </a:r>
             <a:endParaRPr lang="en-US" sz="900" dirty="0"/>
           </a:p>
@@ -14286,7 +14307,7 @@
                 <a:ea typeface="Calibri" pitchFamily="34" charset="-122"/>
                 <a:cs typeface="Calibri" pitchFamily="34" charset="-120"/>
               </a:rPr>
-              <a:t>8</a:t>
+              <a:t>7</a:t>
             </a:r>
             <a:endParaRPr lang="en-US" sz="900" dirty="0"/>
           </a:p>
@@ -14806,7 +14827,7 @@
                 <a:ea typeface="Calibri" pitchFamily="34" charset="-122"/>
                 <a:cs typeface="Calibri" pitchFamily="34" charset="-120"/>
               </a:rPr>
-              <a:t>9</a:t>
+              <a:t>8</a:t>
             </a:r>
             <a:endParaRPr lang="en-US" sz="900" dirty="0"/>
           </a:p>

</xml_diff>